<commit_message>
D2: slides puente con identidad MOVA (teal) en lugar de morado
Co-authored-by: JosefaOgalde <JosefaOgalde@users.noreply.github.com>
</commit_message>
<xml_diff>
--- a/index/clientes/mkof/MOVA-D2-Reglas-mova_auth.pptx
+++ b/index/clientes/mkof/MOVA-D2-Reglas-mova_auth.pptx
@@ -3339,7 +3339,7 @@
     <p:bg>
       <p:bgPr>
         <a:solidFill>
-          <a:srgbClr val="F3EEF8"/>
+          <a:srgbClr val="E8F6F8"/>
         </a:solidFill>
         <a:effectLst/>
       </p:bgPr>
@@ -3366,7 +3366,7 @@
             <a:avLst/>
           </a:prstGeom>
           <a:solidFill>
-            <a:srgbClr val="6F42C1"/>
+            <a:srgbClr val="4A7A80"/>
           </a:solidFill>
           <a:ln>
             <a:noFill/>
@@ -3479,7 +3479,7 @@
             <a:avLst/>
           </a:prstGeom>
           <a:solidFill>
-            <a:srgbClr val="6F42C1"/>
+            <a:srgbClr val="2A4A4E"/>
           </a:solidFill>
           <a:ln>
             <a:noFill/>
@@ -3596,7 +3596,7 @@
           </a:solidFill>
           <a:ln w="25400">
             <a:solidFill>
-              <a:srgbClr val="6F42C1"/>
+              <a:srgbClr val="4A7A80"/>
             </a:solidFill>
           </a:ln>
         </p:spPr>
@@ -3647,7 +3647,7 @@
             <a:pPr algn="l">
               <a:defRPr sz="1200" b="1">
                 <a:solidFill>
-                  <a:srgbClr val="6F42C1"/>
+                  <a:srgbClr val="2A4A4E"/>
                 </a:solidFill>
               </a:defRPr>
             </a:pPr>
@@ -3709,9 +3709,9 @@
           <a:solidFill>
             <a:srgbClr val="FFF8C5"/>
           </a:solidFill>
-          <a:ln w="12700">
+          <a:ln w="25400">
             <a:solidFill>
-              <a:srgbClr val="4A7A80"/>
+              <a:srgbClr val="2A4A4E"/>
             </a:solidFill>
           </a:ln>
         </p:spPr>
@@ -4981,7 +4981,7 @@
     <p:bg>
       <p:bgPr>
         <a:solidFill>
-          <a:srgbClr val="F3EEF8"/>
+          <a:srgbClr val="E8F6F8"/>
         </a:solidFill>
         <a:effectLst/>
       </p:bgPr>
@@ -5008,7 +5008,7 @@
             <a:avLst/>
           </a:prstGeom>
           <a:solidFill>
-            <a:srgbClr val="6F42C1"/>
+            <a:srgbClr val="4A7A80"/>
           </a:solidFill>
           <a:ln>
             <a:noFill/>
@@ -5121,7 +5121,7 @@
             <a:avLst/>
           </a:prstGeom>
           <a:solidFill>
-            <a:srgbClr val="6F42C1"/>
+            <a:srgbClr val="2A4A4E"/>
           </a:solidFill>
           <a:ln>
             <a:noFill/>
@@ -5238,7 +5238,7 @@
           </a:solidFill>
           <a:ln w="25400">
             <a:solidFill>
-              <a:srgbClr val="6F42C1"/>
+              <a:srgbClr val="4A7A80"/>
             </a:solidFill>
           </a:ln>
         </p:spPr>
@@ -5289,7 +5289,7 @@
             <a:pPr algn="l">
               <a:defRPr sz="1200" b="1">
                 <a:solidFill>
-                  <a:srgbClr val="6F42C1"/>
+                  <a:srgbClr val="2A4A4E"/>
                 </a:solidFill>
               </a:defRPr>
             </a:pPr>
@@ -5351,9 +5351,9 @@
           <a:solidFill>
             <a:srgbClr val="FFF8C5"/>
           </a:solidFill>
-          <a:ln w="12700">
+          <a:ln w="25400">
             <a:solidFill>
-              <a:srgbClr val="4A7A80"/>
+              <a:srgbClr val="2A4A4E"/>
             </a:solidFill>
           </a:ln>
         </p:spPr>
@@ -7949,7 +7949,7 @@
     <p:bg>
       <p:bgPr>
         <a:solidFill>
-          <a:srgbClr val="F3EEF8"/>
+          <a:srgbClr val="E8F6F8"/>
         </a:solidFill>
         <a:effectLst/>
       </p:bgPr>
@@ -7976,7 +7976,7 @@
             <a:avLst/>
           </a:prstGeom>
           <a:solidFill>
-            <a:srgbClr val="6F42C1"/>
+            <a:srgbClr val="4A7A80"/>
           </a:solidFill>
           <a:ln>
             <a:noFill/>
@@ -8089,7 +8089,7 @@
             <a:avLst/>
           </a:prstGeom>
           <a:solidFill>
-            <a:srgbClr val="6F42C1"/>
+            <a:srgbClr val="2A4A4E"/>
           </a:solidFill>
           <a:ln>
             <a:noFill/>
@@ -8206,7 +8206,7 @@
           </a:solidFill>
           <a:ln w="25400">
             <a:solidFill>
-              <a:srgbClr val="6F42C1"/>
+              <a:srgbClr val="4A7A80"/>
             </a:solidFill>
           </a:ln>
         </p:spPr>
@@ -8257,7 +8257,7 @@
             <a:pPr algn="l">
               <a:defRPr sz="1200" b="1">
                 <a:solidFill>
-                  <a:srgbClr val="6F42C1"/>
+                  <a:srgbClr val="2A4A4E"/>
                 </a:solidFill>
               </a:defRPr>
             </a:pPr>
@@ -8354,9 +8354,9 @@
           <a:solidFill>
             <a:srgbClr val="FFF8C5"/>
           </a:solidFill>
-          <a:ln w="12700">
+          <a:ln w="25400">
             <a:solidFill>
-              <a:srgbClr val="4A7A80"/>
+              <a:srgbClr val="2A4A4E"/>
             </a:solidFill>
           </a:ln>
         </p:spPr>
@@ -10216,7 +10216,7 @@
     <p:bg>
       <p:bgPr>
         <a:solidFill>
-          <a:srgbClr val="F3EEF8"/>
+          <a:srgbClr val="E8F6F8"/>
         </a:solidFill>
         <a:effectLst/>
       </p:bgPr>
@@ -10243,7 +10243,7 @@
             <a:avLst/>
           </a:prstGeom>
           <a:solidFill>
-            <a:srgbClr val="6F42C1"/>
+            <a:srgbClr val="4A7A80"/>
           </a:solidFill>
           <a:ln>
             <a:noFill/>
@@ -10356,7 +10356,7 @@
             <a:avLst/>
           </a:prstGeom>
           <a:solidFill>
-            <a:srgbClr val="6F42C1"/>
+            <a:srgbClr val="2A4A4E"/>
           </a:solidFill>
           <a:ln>
             <a:noFill/>
@@ -10473,7 +10473,7 @@
           </a:solidFill>
           <a:ln w="25400">
             <a:solidFill>
-              <a:srgbClr val="6F42C1"/>
+              <a:srgbClr val="4A7A80"/>
             </a:solidFill>
           </a:ln>
         </p:spPr>
@@ -10524,7 +10524,7 @@
             <a:pPr algn="l">
               <a:defRPr sz="1200" b="1">
                 <a:solidFill>
-                  <a:srgbClr val="6F42C1"/>
+                  <a:srgbClr val="2A4A4E"/>
                 </a:solidFill>
               </a:defRPr>
             </a:pPr>
@@ -10586,9 +10586,9 @@
           <a:solidFill>
             <a:srgbClr val="FFF8C5"/>
           </a:solidFill>
-          <a:ln w="12700">
+          <a:ln w="25400">
             <a:solidFill>
-              <a:srgbClr val="4A7A80"/>
+              <a:srgbClr val="2A4A4E"/>
             </a:solidFill>
           </a:ln>
         </p:spPr>
@@ -12512,7 +12512,7 @@
     <p:bg>
       <p:bgPr>
         <a:solidFill>
-          <a:srgbClr val="F3EEF8"/>
+          <a:srgbClr val="E8F6F8"/>
         </a:solidFill>
         <a:effectLst/>
       </p:bgPr>
@@ -12539,7 +12539,7 @@
             <a:avLst/>
           </a:prstGeom>
           <a:solidFill>
-            <a:srgbClr val="6F42C1"/>
+            <a:srgbClr val="4A7A80"/>
           </a:solidFill>
           <a:ln>
             <a:noFill/>
@@ -12652,7 +12652,7 @@
             <a:avLst/>
           </a:prstGeom>
           <a:solidFill>
-            <a:srgbClr val="6F42C1"/>
+            <a:srgbClr val="2A4A4E"/>
           </a:solidFill>
           <a:ln>
             <a:noFill/>
@@ -12769,7 +12769,7 @@
           </a:solidFill>
           <a:ln w="25400">
             <a:solidFill>
-              <a:srgbClr val="6F42C1"/>
+              <a:srgbClr val="4A7A80"/>
             </a:solidFill>
           </a:ln>
         </p:spPr>
@@ -12820,7 +12820,7 @@
             <a:pPr algn="l">
               <a:defRPr sz="1200" b="1">
                 <a:solidFill>
-                  <a:srgbClr val="6F42C1"/>
+                  <a:srgbClr val="2A4A4E"/>
                 </a:solidFill>
               </a:defRPr>
             </a:pPr>
@@ -12952,9 +12952,9 @@
           <a:solidFill>
             <a:srgbClr val="FFF8C5"/>
           </a:solidFill>
-          <a:ln w="12700">
+          <a:ln w="25400">
             <a:solidFill>
-              <a:srgbClr val="4A7A80"/>
+              <a:srgbClr val="2A4A4E"/>
             </a:solidFill>
           </a:ln>
         </p:spPr>
@@ -14161,7 +14161,7 @@
     <p:bg>
       <p:bgPr>
         <a:solidFill>
-          <a:srgbClr val="F3EEF8"/>
+          <a:srgbClr val="E8F6F8"/>
         </a:solidFill>
         <a:effectLst/>
       </p:bgPr>
@@ -14188,7 +14188,7 @@
             <a:avLst/>
           </a:prstGeom>
           <a:solidFill>
-            <a:srgbClr val="6F42C1"/>
+            <a:srgbClr val="4A7A80"/>
           </a:solidFill>
           <a:ln>
             <a:noFill/>
@@ -14301,7 +14301,7 @@
             <a:avLst/>
           </a:prstGeom>
           <a:solidFill>
-            <a:srgbClr val="6F42C1"/>
+            <a:srgbClr val="2A4A4E"/>
           </a:solidFill>
           <a:ln>
             <a:noFill/>
@@ -14418,7 +14418,7 @@
           </a:solidFill>
           <a:ln w="25400">
             <a:solidFill>
-              <a:srgbClr val="6F42C1"/>
+              <a:srgbClr val="4A7A80"/>
             </a:solidFill>
           </a:ln>
         </p:spPr>
@@ -14469,7 +14469,7 @@
             <a:pPr algn="l">
               <a:defRPr sz="1200" b="1">
                 <a:solidFill>
-                  <a:srgbClr val="6F42C1"/>
+                  <a:srgbClr val="2A4A4E"/>
                 </a:solidFill>
               </a:defRPr>
             </a:pPr>
@@ -14566,9 +14566,9 @@
           <a:solidFill>
             <a:srgbClr val="FFF8C5"/>
           </a:solidFill>
-          <a:ln w="12700">
+          <a:ln w="25400">
             <a:solidFill>
-              <a:srgbClr val="4A7A80"/>
+              <a:srgbClr val="2A4A4E"/>
             </a:solidFill>
           </a:ln>
         </p:spPr>
@@ -15543,7 +15543,7 @@
     <p:bg>
       <p:bgPr>
         <a:solidFill>
-          <a:srgbClr val="F3EEF8"/>
+          <a:srgbClr val="E8F6F8"/>
         </a:solidFill>
         <a:effectLst/>
       </p:bgPr>
@@ -15570,7 +15570,7 @@
             <a:avLst/>
           </a:prstGeom>
           <a:solidFill>
-            <a:srgbClr val="6F42C1"/>
+            <a:srgbClr val="4A7A80"/>
           </a:solidFill>
           <a:ln>
             <a:noFill/>
@@ -15683,7 +15683,7 @@
             <a:avLst/>
           </a:prstGeom>
           <a:solidFill>
-            <a:srgbClr val="6F42C1"/>
+            <a:srgbClr val="2A4A4E"/>
           </a:solidFill>
           <a:ln>
             <a:noFill/>
@@ -15800,7 +15800,7 @@
           </a:solidFill>
           <a:ln w="25400">
             <a:solidFill>
-              <a:srgbClr val="6F42C1"/>
+              <a:srgbClr val="4A7A80"/>
             </a:solidFill>
           </a:ln>
         </p:spPr>
@@ -15851,7 +15851,7 @@
             <a:pPr algn="l">
               <a:defRPr sz="1200" b="1">
                 <a:solidFill>
-                  <a:srgbClr val="6F42C1"/>
+                  <a:srgbClr val="2A4A4E"/>
                 </a:solidFill>
               </a:defRPr>
             </a:pPr>
@@ -15948,9 +15948,9 @@
           <a:solidFill>
             <a:srgbClr val="FFF8C5"/>
           </a:solidFill>
-          <a:ln w="12700">
+          <a:ln w="25400">
             <a:solidFill>
-              <a:srgbClr val="4A7A80"/>
+              <a:srgbClr val="2A4A4E"/>
             </a:solidFill>
           </a:ln>
         </p:spPr>

</xml_diff>